<commit_message>
feat: change titles for slides
</commit_message>
<xml_diff>
--- a/compliance/research_presentation.pptx
+++ b/compliance/research_presentation.pptx
@@ -12159,7 +12159,7 @@
                   <a:srgbClr val="094183"/>
                 </a:solidFill>
               </a:rPr>
-              <a:t>Coverage</a:t>
+              <a:t>Results</a:t>
             </a:r>
             <a:endParaRPr>
               <a:solidFill>
@@ -14966,7 +14966,7 @@
                   <a:srgbClr val="094183"/>
                 </a:solidFill>
               </a:rPr>
-              <a:t>Summary</a:t>
+              <a:t>Results</a:t>
             </a:r>
             <a:endParaRPr>
               <a:solidFill>
@@ -16354,7 +16354,7 @@
                   <a:srgbClr val="094183"/>
                 </a:solidFill>
               </a:rPr>
-              <a:t>Summary</a:t>
+              <a:t>Results</a:t>
             </a:r>
             <a:endParaRPr>
               <a:solidFill>

</xml_diff>